<commit_message>
Deck: make the temporal loop read as across-frames recurrence, not Phase3->Phase1
On slide 6 the dashed orange loop ran from Pass 3 back to Pass 1, which a
literal reading takes as a within-frame data edge (Pass 3's output feeding
Pass 1). It isn't -- the temporal memory module is a Phase-1 recurrence
that carries state to the NEXT frame. Relabeled the HTML loop
"+ ours: remember time - across frames" with a "next frame" tag at the
arrowhead so the recurrence is unambiguous, and reworded the pptx badge to
"state carried to the next frame". Regenerated the .pptx from the updated
generator.
</commit_message>
<xml_diff>
--- a/docs/presentation/instancedepth-journey.pptx
+++ b/docs/presentation/instancedepth-journey.pptx
@@ -12826,8 +12826,8 @@
         </p:nvSpPr>
         <p:spPr>
           <a:xfrm>
-            <a:off x="4023360" y="4846320"/>
-            <a:ext cx="4206240" cy="640080"/>
+            <a:off x="3566160" y="4846320"/>
+            <a:ext cx="5120640" cy="640080"/>
           </a:xfrm>
           <a:prstGeom prst="roundRect">
             <a:avLst>
@@ -12874,8 +12874,8 @@
         </p:nvSpPr>
         <p:spPr>
           <a:xfrm>
-            <a:off x="4023360" y="4846320"/>
-            <a:ext cx="4206240" cy="640080"/>
+            <a:off x="3566160" y="4846320"/>
+            <a:ext cx="5120640" cy="640080"/>
           </a:xfrm>
           <a:prstGeom prst="rect">
             <a:avLst/>
@@ -12890,13 +12890,13 @@
           <a:p>
             <a:pPr algn="ctr"/>
             <a:r>
-              <a:rPr sz="1600" b="1">
+              <a:rPr sz="1500" b="1">
                 <a:solidFill>
                   <a:srgbClr val="F2836C"/>
                 </a:solidFill>
                 <a:latin typeface="Segoe UI"/>
               </a:rPr>
-              <a:t>+ ours: remember time (between frames)</a:t>
+              <a:t>+ ours: remember time -- state carried to the next frame</a:t>
             </a:r>
           </a:p>
         </p:txBody>

</xml_diff>

<commit_message>
Deck: redraw temporal loop as a memory band, not a Pass3->Pass1 arrow
Previous fix only relabeled the arrow; its geometry still ran Pass 3 ->
Pass 1, so it still *looked* like a within-frame edge. Replaced the long
loop with a dashed "memory" band spanning under the whole per-frame
pipeline plus a short recurrence arrow up into Pass 1 only, labelled
"next frame" -- so nothing visually connects Pass 3 back to Pass 1. pptx
badge widened into the same band under all three passes and reworded.
Regenerated the .pptx.
</commit_message>
<xml_diff>
--- a/docs/presentation/instancedepth-journey.pptx
+++ b/docs/presentation/instancedepth-journey.pptx
@@ -12826,8 +12826,8 @@
         </p:nvSpPr>
         <p:spPr>
           <a:xfrm>
-            <a:off x="3566160" y="4846320"/>
-            <a:ext cx="5120640" cy="640080"/>
+            <a:off x="2834640" y="4892040"/>
+            <a:ext cx="8366760" cy="566928"/>
           </a:xfrm>
           <a:prstGeom prst="roundRect">
             <a:avLst>
@@ -12874,8 +12874,8 @@
         </p:nvSpPr>
         <p:spPr>
           <a:xfrm>
-            <a:off x="3566160" y="4846320"/>
-            <a:ext cx="5120640" cy="640080"/>
+            <a:off x="2834640" y="4892040"/>
+            <a:ext cx="8366760" cy="566928"/>
           </a:xfrm>
           <a:prstGeom prst="rect">
             <a:avLst/>
@@ -12890,13 +12890,13 @@
           <a:p>
             <a:pPr algn="ctr"/>
             <a:r>
-              <a:rPr sz="1500" b="1">
+              <a:rPr sz="1400" b="1">
                 <a:solidFill>
                   <a:srgbClr val="F2836C"/>
                 </a:solidFill>
                 <a:latin typeface="Segoe UI"/>
               </a:rPr>
-              <a:t>+ ours: remember time -- state carried to the next frame</a:t>
+              <a:t>+ ours: memory -- keeps each person across frames (feeds the next frame's Pass 1)</a:t>
             </a:r>
           </a:p>
         </p:txBody>

</xml_diff>